<commit_message>
ITB STEI: tambah template PowerPoint (.potx)
</commit_message>
<xml_diff>
--- a/itb-stei/libreoffice/contoh-itb.pptx
+++ b/itb-stei/libreoffice/contoh-itb.pptx
@@ -322,7 +322,7 @@
         <p:txBody>
           <a:bodyPr/>
           <a:p>
-            <a:fld id="{26B7382E-8BB8-4E67-BF1A-24DFC4BD2481}" type="slidenum">
+            <a:fld id="{ADC0C5D0-BBF7-4FEB-B9B9-E2EF6C4C8B94}" type="slidenum">
               <a:t>&lt;#&gt;</a:t>
             </a:fld>
           </a:p>
@@ -424,7 +424,7 @@
         <p:txBody>
           <a:bodyPr/>
           <a:p>
-            <a:fld id="{74F71292-DBDB-449E-9B59-E042078699CA}" type="slidenum">
+            <a:fld id="{682BB6E7-EDA9-4E46-BA7B-986B144AF9A1}" type="slidenum">
               <a:t>&lt;#&gt;</a:t>
             </a:fld>
           </a:p>
@@ -588,7 +588,7 @@
         <p:txBody>
           <a:bodyPr/>
           <a:p>
-            <a:fld id="{93237E2E-16D0-4AC5-B5E7-21414E87286B}" type="slidenum">
+            <a:fld id="{971C2412-06B5-456B-890C-8614492B7B21}" type="slidenum">
               <a:t>&lt;#&gt;</a:t>
             </a:fld>
           </a:p>
@@ -1522,7 +1522,7 @@
             <a:pPr indent="0" algn="r">
               <a:buNone/>
             </a:pPr>
-            <a:fld id="{DD7B3085-D0E1-4A62-8383-8B962793F545}" type="slidenum">
+            <a:fld id="{FB54DE4A-22C0-4BF8-9006-557AF0E026E1}" type="slidenum">
               <a:rPr b="0" lang="en-US" sz="1110" spc="-1" strike="noStrike">
                 <a:solidFill>
                   <a:srgbClr val="005aab"/>
@@ -2230,7 +2230,7 @@
             <a:pPr indent="0" algn="r">
               <a:buNone/>
             </a:pPr>
-            <a:fld id="{CAE3F5F9-A250-4E59-AFC3-7CE81ADF9769}" type="slidenum">
+            <a:fld id="{DC4F1848-A4F8-41C9-81C5-0F503FA5626D}" type="slidenum">
               <a:rPr b="0" lang="en-US" sz="1110" spc="-1" strike="noStrike">
                 <a:solidFill>
                   <a:srgbClr val="005aab"/>

</xml_diff>

<commit_message>
ITB STEI: hapus .potx, template PowerPoint cukup .pptx
</commit_message>
<xml_diff>
--- a/itb-stei/libreoffice/contoh-itb.pptx
+++ b/itb-stei/libreoffice/contoh-itb.pptx
@@ -322,7 +322,7 @@
         <p:txBody>
           <a:bodyPr/>
           <a:p>
-            <a:fld id="{ADC0C5D0-BBF7-4FEB-B9B9-E2EF6C4C8B94}" type="slidenum">
+            <a:fld id="{EC44BCC4-2473-4162-8FFE-B0A570EA1775}" type="slidenum">
               <a:t>&lt;#&gt;</a:t>
             </a:fld>
           </a:p>
@@ -424,7 +424,7 @@
         <p:txBody>
           <a:bodyPr/>
           <a:p>
-            <a:fld id="{682BB6E7-EDA9-4E46-BA7B-986B144AF9A1}" type="slidenum">
+            <a:fld id="{D31757CD-63C8-4250-8C41-B35AA03F3757}" type="slidenum">
               <a:t>&lt;#&gt;</a:t>
             </a:fld>
           </a:p>
@@ -588,7 +588,7 @@
         <p:txBody>
           <a:bodyPr/>
           <a:p>
-            <a:fld id="{971C2412-06B5-456B-890C-8614492B7B21}" type="slidenum">
+            <a:fld id="{124315F9-AFB7-4E69-86B5-0C1A9BDECC77}" type="slidenum">
               <a:t>&lt;#&gt;</a:t>
             </a:fld>
           </a:p>
@@ -1522,7 +1522,7 @@
             <a:pPr indent="0" algn="r">
               <a:buNone/>
             </a:pPr>
-            <a:fld id="{FB54DE4A-22C0-4BF8-9006-557AF0E026E1}" type="slidenum">
+            <a:fld id="{13E260DC-7BBD-4D3F-8D0F-5D4AE1D74A92}" type="slidenum">
               <a:rPr b="0" lang="en-US" sz="1110" spc="-1" strike="noStrike">
                 <a:solidFill>
                   <a:srgbClr val="005aab"/>
@@ -2230,7 +2230,7 @@
             <a:pPr indent="0" algn="r">
               <a:buNone/>
             </a:pPr>
-            <a:fld id="{DC4F1848-A4F8-41C9-81C5-0F503FA5626D}" type="slidenum">
+            <a:fld id="{28125E08-8E07-45AA-B960-A28D2C3E4AF5}" type="slidenum">
               <a:rPr b="0" lang="en-US" sz="1110" spc="-1" strike="noStrike">
                 <a:solidFill>
                   <a:srgbClr val="005aab"/>

</xml_diff>

<commit_message>
ITB STEI: slide penutup dengan logo ITB serta nama, NIM, email dan web
</commit_message>
<xml_diff>
--- a/itb-stei/libreoffice/contoh-itb.pptx
+++ b/itb-stei/libreoffice/contoh-itb.pptx
@@ -53,8 +53,8 @@
         </p:nvSpPr>
         <p:spPr>
           <a:xfrm>
-            <a:off x="0" y="1980000"/>
-            <a:ext cx="9144000" cy="1080000"/>
+            <a:off x="0" y="1198800"/>
+            <a:ext cx="9144000" cy="396000"/>
           </a:xfrm>
           <a:prstGeom prst="rect">
             <a:avLst/>
@@ -65,7 +65,7 @@
           </a:ln>
         </p:spPr>
         <p:txBody>
-          <a:bodyPr lIns="0" rIns="0" tIns="0" bIns="0" anchor="ctr">
+          <a:bodyPr lIns="0" rIns="0" tIns="0" bIns="0" anchor="t">
             <a:noAutofit/>
           </a:bodyPr>
           <a:p>
@@ -115,8 +115,8 @@
         </p:nvSpPr>
         <p:spPr>
           <a:xfrm>
-            <a:off x="0" y="1980000"/>
-            <a:ext cx="9144000" cy="1080000"/>
+            <a:off x="0" y="1198800"/>
+            <a:ext cx="9144000" cy="396000"/>
           </a:xfrm>
           <a:prstGeom prst="rect">
             <a:avLst/>
@@ -127,7 +127,7 @@
           </a:ln>
         </p:spPr>
         <p:txBody>
-          <a:bodyPr lIns="0" rIns="0" tIns="0" bIns="0" anchor="ctr">
+          <a:bodyPr lIns="0" rIns="0" tIns="0" bIns="0" anchor="t">
             <a:noAutofit/>
           </a:bodyPr>
           <a:p>
@@ -217,8 +217,8 @@
         </p:nvSpPr>
         <p:spPr>
           <a:xfrm>
-            <a:off x="0" y="1980000"/>
-            <a:ext cx="9144000" cy="1080000"/>
+            <a:off x="0" y="1198800"/>
+            <a:ext cx="9144000" cy="396000"/>
           </a:xfrm>
           <a:prstGeom prst="rect">
             <a:avLst/>
@@ -229,7 +229,7 @@
           </a:ln>
         </p:spPr>
         <p:txBody>
-          <a:bodyPr lIns="0" rIns="0" tIns="0" bIns="0" anchor="ctr">
+          <a:bodyPr lIns="0" rIns="0" tIns="0" bIns="0" anchor="t">
             <a:noAutofit/>
           </a:bodyPr>
           <a:p>
@@ -322,7 +322,7 @@
         <p:txBody>
           <a:bodyPr/>
           <a:p>
-            <a:fld id="{EC44BCC4-2473-4162-8FFE-B0A570EA1775}" type="slidenum">
+            <a:fld id="{D3CC7FC8-6198-4348-8597-7F0F9BAA8B28}" type="slidenum">
               <a:t>&lt;#&gt;</a:t>
             </a:fld>
           </a:p>
@@ -362,8 +362,8 @@
         </p:nvSpPr>
         <p:spPr>
           <a:xfrm>
-            <a:off x="0" y="1980000"/>
-            <a:ext cx="9144000" cy="1080000"/>
+            <a:off x="0" y="1198800"/>
+            <a:ext cx="9144000" cy="396000"/>
           </a:xfrm>
           <a:prstGeom prst="rect">
             <a:avLst/>
@@ -374,7 +374,7 @@
           </a:ln>
         </p:spPr>
         <p:txBody>
-          <a:bodyPr lIns="0" rIns="0" tIns="0" bIns="0" anchor="ctr">
+          <a:bodyPr lIns="0" rIns="0" tIns="0" bIns="0" anchor="t">
             <a:noAutofit/>
           </a:bodyPr>
           <a:p>
@@ -424,7 +424,7 @@
         <p:txBody>
           <a:bodyPr/>
           <a:p>
-            <a:fld id="{D31757CD-63C8-4250-8C41-B35AA03F3757}" type="slidenum">
+            <a:fld id="{A2E39E3E-5508-4A26-A79C-9A5F8C3F91DD}" type="slidenum">
               <a:t>&lt;#&gt;</a:t>
             </a:fld>
           </a:p>
@@ -464,8 +464,8 @@
         </p:nvSpPr>
         <p:spPr>
           <a:xfrm>
-            <a:off x="0" y="1980000"/>
-            <a:ext cx="9144000" cy="1080000"/>
+            <a:off x="0" y="1198800"/>
+            <a:ext cx="9144000" cy="396000"/>
           </a:xfrm>
           <a:prstGeom prst="rect">
             <a:avLst/>
@@ -476,7 +476,7 @@
           </a:ln>
         </p:spPr>
         <p:txBody>
-          <a:bodyPr lIns="0" rIns="0" tIns="0" bIns="0" anchor="ctr">
+          <a:bodyPr lIns="0" rIns="0" tIns="0" bIns="0" anchor="t">
             <a:noAutofit/>
           </a:bodyPr>
           <a:p>
@@ -516,7 +516,7 @@
       </p:grpSpPr>
       <p:sp>
         <p:nvSpPr>
-          <p:cNvPr id="32" name="PlaceHolder 1"/>
+          <p:cNvPr id="34" name="PlaceHolder 1"/>
           <p:cNvSpPr>
             <a:spLocks noGrp="1"/>
           </p:cNvSpPr>
@@ -526,8 +526,8 @@
         </p:nvSpPr>
         <p:spPr>
           <a:xfrm>
-            <a:off x="0" y="1980000"/>
-            <a:ext cx="9144000" cy="1080000"/>
+            <a:off x="0" y="1198800"/>
+            <a:ext cx="9144000" cy="396000"/>
           </a:xfrm>
           <a:prstGeom prst="rect">
             <a:avLst/>
@@ -538,7 +538,7 @@
           </a:ln>
         </p:spPr>
         <p:txBody>
-          <a:bodyPr lIns="0" rIns="0" tIns="0" bIns="0" anchor="ctr">
+          <a:bodyPr lIns="0" rIns="0" tIns="0" bIns="0" anchor="t">
             <a:noAutofit/>
           </a:bodyPr>
           <a:p>
@@ -588,7 +588,7 @@
         <p:txBody>
           <a:bodyPr/>
           <a:p>
-            <a:fld id="{124315F9-AFB7-4E69-86B5-0C1A9BDECC77}" type="slidenum">
+            <a:fld id="{602D4D47-9A3A-46E2-B930-460BC411E1AF}" type="slidenum">
               <a:t>&lt;#&gt;</a:t>
             </a:fld>
           </a:p>
@@ -1522,7 +1522,7 @@
             <a:pPr indent="0" algn="r">
               <a:buNone/>
             </a:pPr>
-            <a:fld id="{13E260DC-7BBD-4D3F-8D0F-5D4AE1D74A92}" type="slidenum">
+            <a:fld id="{D84E7B9B-7A70-4077-9A70-7B2957BE3AC2}" type="slidenum">
               <a:rPr b="0" lang="en-US" sz="1110" spc="-1" strike="noStrike">
                 <a:solidFill>
                   <a:srgbClr val="005aab"/>
@@ -2091,8 +2091,8 @@
         </p:nvSpPr>
         <p:spPr>
           <a:xfrm>
-            <a:off x="0" y="1980000"/>
-            <a:ext cx="9144000" cy="1080000"/>
+            <a:off x="0" y="1198800"/>
+            <a:ext cx="9144000" cy="396000"/>
           </a:xfrm>
           <a:prstGeom prst="rect">
             <a:avLst/>
@@ -2103,7 +2103,7 @@
           </a:ln>
         </p:spPr>
         <p:txBody>
-          <a:bodyPr lIns="0" rIns="0" tIns="0" bIns="0" anchor="ctr">
+          <a:bodyPr lIns="0" rIns="0" tIns="0" bIns="0" anchor="t">
             <a:noAutofit/>
           </a:bodyPr>
           <a:p>
@@ -2130,7 +2130,65 @@
       </p:sp>
       <p:sp>
         <p:nvSpPr>
-          <p:cNvPr id="29" name="PlaceHolder 2"/>
+          <p:cNvPr id="29" name=""/>
+          <p:cNvSpPr/>
+          <p:nvPr/>
+        </p:nvSpPr>
+        <p:spPr>
+          <a:xfrm>
+            <a:off x="4114800" y="2829600"/>
+            <a:ext cx="914400" cy="914400"/>
+          </a:xfrm>
+          <a:prstGeom prst="ellipse">
+            <a:avLst/>
+          </a:prstGeom>
+          <a:solidFill>
+            <a:srgbClr val="ffffff"/>
+          </a:solidFill>
+          <a:ln w="0">
+            <a:noFill/>
+          </a:ln>
+        </p:spPr>
+        <p:txBody>
+          <a:bodyPr lIns="0" rIns="0" tIns="0" bIns="0" anchor="t">
+            <a:noAutofit/>
+          </a:bodyPr>
+          <a:p>
+            <a:endParaRPr b="0" lang="en-US" sz="1580" spc="-1" strike="noStrike">
+              <a:solidFill>
+                <a:srgbClr val="212121"/>
+              </a:solidFill>
+              <a:latin typeface="Fira Sans Book"/>
+            </a:endParaRPr>
+          </a:p>
+        </p:txBody>
+      </p:sp>
+      <p:pic>
+        <p:nvPicPr>
+          <p:cNvPr id="30" name="" descr=""/>
+          <p:cNvPicPr/>
+          <p:nvPr/>
+        </p:nvPicPr>
+        <p:blipFill>
+          <a:blip r:embed="rId2"/>
+          <a:stretch/>
+        </p:blipFill>
+        <p:spPr>
+          <a:xfrm>
+            <a:off x="4172040" y="2886840"/>
+            <a:ext cx="799920" cy="799920"/>
+          </a:xfrm>
+          <a:prstGeom prst="rect">
+            <a:avLst/>
+          </a:prstGeom>
+          <a:ln w="0">
+            <a:noFill/>
+          </a:ln>
+        </p:spPr>
+      </p:pic>
+      <p:sp>
+        <p:nvSpPr>
+          <p:cNvPr id="31" name="PlaceHolder 2"/>
           <p:cNvSpPr>
             <a:spLocks noGrp="1"/>
           </p:cNvSpPr>
@@ -2190,7 +2248,7 @@
       </p:sp>
       <p:sp>
         <p:nvSpPr>
-          <p:cNvPr id="30" name="PlaceHolder 3"/>
+          <p:cNvPr id="32" name="PlaceHolder 3"/>
           <p:cNvSpPr>
             <a:spLocks noGrp="1"/>
           </p:cNvSpPr>
@@ -2230,7 +2288,7 @@
             <a:pPr indent="0" algn="r">
               <a:buNone/>
             </a:pPr>
-            <a:fld id="{28125E08-8E07-45AA-B960-A28D2C3E4AF5}" type="slidenum">
+            <a:fld id="{BCF542D1-9D93-46AE-96B7-D99EE55A2A1F}" type="slidenum">
               <a:rPr b="0" lang="en-US" sz="1110" spc="-1" strike="noStrike">
                 <a:solidFill>
                   <a:srgbClr val="005aab"/>
@@ -2250,7 +2308,7 @@
       </p:sp>
       <p:sp>
         <p:nvSpPr>
-          <p:cNvPr id="31" name="PlaceHolder 4"/>
+          <p:cNvPr id="33" name="PlaceHolder 4"/>
           <p:cNvSpPr>
             <a:spLocks noGrp="1"/>
           </p:cNvSpPr>
@@ -2471,7 +2529,7 @@
   </p:cSld>
   <p:clrMap bg1="lt1" bg2="lt2" tx1="dk1" tx2="dk2" accent1="accent1" accent2="accent2" accent3="accent3" accent4="accent4" accent5="accent5" accent6="accent6" hlink="hlink" folHlink="folHlink"/>
   <p:sldLayoutIdLst>
-    <p:sldLayoutId id="2147483657" r:id="rId2"/>
+    <p:sldLayoutId id="2147483657" r:id="rId3"/>
   </p:sldLayoutIdLst>
 </p:sldMaster>
 </file>
@@ -2495,7 +2553,7 @@
       </p:grpSpPr>
       <p:sp>
         <p:nvSpPr>
-          <p:cNvPr id="33" name="PlaceHolder 1"/>
+          <p:cNvPr id="35" name="PlaceHolder 1"/>
           <p:cNvSpPr>
             <a:spLocks noGrp="1"/>
           </p:cNvSpPr>
@@ -2544,7 +2602,7 @@
       </p:sp>
       <p:sp>
         <p:nvSpPr>
-          <p:cNvPr id="34" name="PlaceHolder 2"/>
+          <p:cNvPr id="36" name="PlaceHolder 2"/>
           <p:cNvSpPr>
             <a:spLocks noGrp="1"/>
           </p:cNvSpPr>
@@ -2593,7 +2651,7 @@
       </p:sp>
       <p:sp>
         <p:nvSpPr>
-          <p:cNvPr id="35" name=""/>
+          <p:cNvPr id="37" name=""/>
           <p:cNvSpPr txBox="1"/>
           <p:nvPr/>
         </p:nvSpPr>
@@ -2635,7 +2693,7 @@
       </p:sp>
       <p:sp>
         <p:nvSpPr>
-          <p:cNvPr id="36" name=""/>
+          <p:cNvPr id="38" name=""/>
           <p:cNvSpPr txBox="1"/>
           <p:nvPr/>
         </p:nvSpPr>
@@ -2677,7 +2735,7 @@
       </p:sp>
       <p:sp>
         <p:nvSpPr>
-          <p:cNvPr id="37" name=""/>
+          <p:cNvPr id="39" name=""/>
           <p:cNvSpPr txBox="1"/>
           <p:nvPr/>
         </p:nvSpPr>
@@ -2719,7 +2777,7 @@
       </p:sp>
       <p:sp>
         <p:nvSpPr>
-          <p:cNvPr id="38" name=""/>
+          <p:cNvPr id="40" name=""/>
           <p:cNvSpPr txBox="1"/>
           <p:nvPr/>
         </p:nvSpPr>
@@ -2761,7 +2819,7 @@
       </p:sp>
       <p:sp>
         <p:nvSpPr>
-          <p:cNvPr id="39" name=""/>
+          <p:cNvPr id="41" name=""/>
           <p:cNvSpPr txBox="1"/>
           <p:nvPr/>
         </p:nvSpPr>
@@ -3076,7 +3134,7 @@
       </p:grpSpPr>
       <p:sp>
         <p:nvSpPr>
-          <p:cNvPr id="134" name="PlaceHolder 1"/>
+          <p:cNvPr id="136" name="PlaceHolder 1"/>
           <p:cNvSpPr>
             <a:spLocks noGrp="1"/>
           </p:cNvSpPr>
@@ -3086,8 +3144,8 @@
         </p:nvSpPr>
         <p:spPr>
           <a:xfrm>
-            <a:off x="0" y="1980000"/>
-            <a:ext cx="9144000" cy="1080000"/>
+            <a:off x="0" y="1198800"/>
+            <a:ext cx="9144000" cy="396000"/>
           </a:xfrm>
           <a:prstGeom prst="rect">
             <a:avLst/>
@@ -3098,7 +3156,7 @@
           </a:ln>
         </p:spPr>
         <p:txBody>
-          <a:bodyPr lIns="0" rIns="0" tIns="0" bIns="0" anchor="ctr">
+          <a:bodyPr lIns="0" rIns="0" tIns="0" bIns="0" anchor="t">
             <a:noAutofit/>
           </a:bodyPr>
           <a:p>
@@ -3125,7 +3183,93 @@
       </p:sp>
       <p:sp>
         <p:nvSpPr>
-          <p:cNvPr id="135" name=""/>
+          <p:cNvPr id="137" name=""/>
+          <p:cNvSpPr txBox="1"/>
+          <p:nvPr/>
+        </p:nvSpPr>
+        <p:spPr>
+          <a:xfrm>
+            <a:off x="0" y="1785600"/>
+            <a:ext cx="9144000" cy="288000"/>
+          </a:xfrm>
+          <a:prstGeom prst="rect">
+            <a:avLst/>
+          </a:prstGeom>
+          <a:noFill/>
+          <a:ln w="0">
+            <a:noFill/>
+          </a:ln>
+        </p:spPr>
+        <p:txBody>
+          <a:bodyPr lIns="0" rIns="0" tIns="0" bIns="0" anchor="t">
+            <a:noAutofit/>
+          </a:bodyPr>
+          <a:p>
+            <a:pPr algn="ctr"/>
+            <a:r>
+              <a:rPr b="1" lang="en-US" sz="1580" spc="-1" strike="noStrike">
+                <a:solidFill>
+                  <a:srgbClr val="ffffff"/>
+                </a:solidFill>
+                <a:latin typeface="Fira Sans"/>
+              </a:rPr>
+              <a:t>Nama Anda · NIM</a:t>
+            </a:r>
+            <a:endParaRPr b="1" lang="en-US" sz="1580" spc="-1" strike="noStrike">
+              <a:solidFill>
+                <a:srgbClr val="ffffff"/>
+              </a:solidFill>
+              <a:latin typeface="Fira Sans"/>
+            </a:endParaRPr>
+          </a:p>
+        </p:txBody>
+      </p:sp>
+      <p:sp>
+        <p:nvSpPr>
+          <p:cNvPr id="138" name=""/>
+          <p:cNvSpPr txBox="1"/>
+          <p:nvPr/>
+        </p:nvSpPr>
+        <p:spPr>
+          <a:xfrm>
+            <a:off x="0" y="2296800"/>
+            <a:ext cx="9144000" cy="252000"/>
+          </a:xfrm>
+          <a:prstGeom prst="rect">
+            <a:avLst/>
+          </a:prstGeom>
+          <a:noFill/>
+          <a:ln w="0">
+            <a:noFill/>
+          </a:ln>
+        </p:spPr>
+        <p:txBody>
+          <a:bodyPr lIns="0" rIns="0" tIns="0" bIns="0" anchor="t">
+            <a:noAutofit/>
+          </a:bodyPr>
+          <a:p>
+            <a:pPr algn="ctr"/>
+            <a:r>
+              <a:rPr b="1" lang="en-US" sz="1270" spc="-1" strike="noStrike">
+                <a:solidFill>
+                  <a:srgbClr val="ffffff"/>
+                </a:solidFill>
+                <a:latin typeface="Fira Sans"/>
+              </a:rPr>
+              <a:t>nim@mahasiswa.itb.ac.id · situs-anda.id</a:t>
+            </a:r>
+            <a:endParaRPr b="1" lang="en-US" sz="1270" spc="-1" strike="noStrike">
+              <a:solidFill>
+                <a:srgbClr val="ffffff"/>
+              </a:solidFill>
+              <a:latin typeface="Fira Sans"/>
+            </a:endParaRPr>
+          </a:p>
+        </p:txBody>
+      </p:sp>
+      <p:sp>
+        <p:nvSpPr>
+          <p:cNvPr id="139" name=""/>
           <p:cNvSpPr txBox="1"/>
           <p:nvPr/>
         </p:nvSpPr>
@@ -3218,7 +3362,7 @@
       </p:grpSpPr>
       <p:sp>
         <p:nvSpPr>
-          <p:cNvPr id="40" name="PlaceHolder 1"/>
+          <p:cNvPr id="42" name="PlaceHolder 1"/>
           <p:cNvSpPr>
             <a:spLocks noGrp="1"/>
           </p:cNvSpPr>
@@ -3267,7 +3411,7 @@
       </p:sp>
       <p:sp>
         <p:nvSpPr>
-          <p:cNvPr id="41" name=""/>
+          <p:cNvPr id="43" name=""/>
           <p:cNvSpPr/>
           <p:nvPr/>
         </p:nvSpPr>
@@ -3308,7 +3452,7 @@
       </p:sp>
       <p:sp>
         <p:nvSpPr>
-          <p:cNvPr id="42" name=""/>
+          <p:cNvPr id="44" name=""/>
           <p:cNvSpPr/>
           <p:nvPr/>
         </p:nvSpPr>
@@ -3368,7 +3512,7 @@
       </p:sp>
       <p:sp>
         <p:nvSpPr>
-          <p:cNvPr id="43" name=""/>
+          <p:cNvPr id="45" name=""/>
           <p:cNvSpPr/>
           <p:nvPr/>
         </p:nvSpPr>
@@ -3419,7 +3563,7 @@
       </p:sp>
       <p:sp>
         <p:nvSpPr>
-          <p:cNvPr id="44" name=""/>
+          <p:cNvPr id="46" name=""/>
           <p:cNvSpPr/>
           <p:nvPr/>
         </p:nvSpPr>
@@ -3537,7 +3681,7 @@
       </p:sp>
       <p:sp>
         <p:nvSpPr>
-          <p:cNvPr id="45" name=""/>
+          <p:cNvPr id="47" name=""/>
           <p:cNvSpPr/>
           <p:nvPr/>
         </p:nvSpPr>
@@ -3588,7 +3732,7 @@
       </p:sp>
       <p:sp>
         <p:nvSpPr>
-          <p:cNvPr id="46" name=""/>
+          <p:cNvPr id="48" name=""/>
           <p:cNvSpPr/>
           <p:nvPr/>
         </p:nvSpPr>
@@ -3648,7 +3792,7 @@
       </p:sp>
       <p:sp>
         <p:nvSpPr>
-          <p:cNvPr id="47" name=""/>
+          <p:cNvPr id="49" name=""/>
           <p:cNvSpPr/>
           <p:nvPr/>
         </p:nvSpPr>
@@ -3699,7 +3843,7 @@
       </p:sp>
       <p:sp>
         <p:nvSpPr>
-          <p:cNvPr id="48" name=""/>
+          <p:cNvPr id="50" name=""/>
           <p:cNvSpPr/>
           <p:nvPr/>
         </p:nvSpPr>
@@ -3759,7 +3903,7 @@
       </p:sp>
       <p:sp>
         <p:nvSpPr>
-          <p:cNvPr id="49" name=""/>
+          <p:cNvPr id="51" name=""/>
           <p:cNvSpPr/>
           <p:nvPr/>
         </p:nvSpPr>
@@ -3810,7 +3954,7 @@
       </p:sp>
       <p:sp>
         <p:nvSpPr>
-          <p:cNvPr id="50" name=""/>
+          <p:cNvPr id="52" name=""/>
           <p:cNvSpPr/>
           <p:nvPr/>
         </p:nvSpPr>
@@ -3870,7 +4014,7 @@
       </p:sp>
       <p:sp>
         <p:nvSpPr>
-          <p:cNvPr id="51" name=""/>
+          <p:cNvPr id="53" name=""/>
           <p:cNvSpPr/>
           <p:nvPr/>
         </p:nvSpPr>
@@ -3921,7 +4065,7 @@
       </p:sp>
       <p:sp>
         <p:nvSpPr>
-          <p:cNvPr id="52" name=""/>
+          <p:cNvPr id="54" name=""/>
           <p:cNvSpPr/>
           <p:nvPr/>
         </p:nvSpPr>
@@ -3981,7 +4125,7 @@
       </p:sp>
       <p:sp>
         <p:nvSpPr>
-          <p:cNvPr id="53" name=""/>
+          <p:cNvPr id="55" name=""/>
           <p:cNvSpPr/>
           <p:nvPr/>
         </p:nvSpPr>
@@ -4032,7 +4176,7 @@
       </p:sp>
       <p:sp>
         <p:nvSpPr>
-          <p:cNvPr id="54" name=""/>
+          <p:cNvPr id="56" name=""/>
           <p:cNvSpPr/>
           <p:nvPr/>
         </p:nvSpPr>
@@ -4146,7 +4290,7 @@
       </p:sp>
       <p:sp>
         <p:nvSpPr>
-          <p:cNvPr id="55" name=""/>
+          <p:cNvPr id="57" name=""/>
           <p:cNvSpPr/>
           <p:nvPr/>
         </p:nvSpPr>
@@ -4197,7 +4341,7 @@
       </p:sp>
       <p:sp>
         <p:nvSpPr>
-          <p:cNvPr id="56" name=""/>
+          <p:cNvPr id="58" name=""/>
           <p:cNvSpPr/>
           <p:nvPr/>
         </p:nvSpPr>
@@ -4311,7 +4455,7 @@
       </p:sp>
       <p:sp>
         <p:nvSpPr>
-          <p:cNvPr id="57" name=""/>
+          <p:cNvPr id="59" name=""/>
           <p:cNvSpPr/>
           <p:nvPr/>
         </p:nvSpPr>
@@ -4362,7 +4506,7 @@
       </p:sp>
       <p:sp>
         <p:nvSpPr>
-          <p:cNvPr id="58" name=""/>
+          <p:cNvPr id="60" name=""/>
           <p:cNvSpPr txBox="1"/>
           <p:nvPr/>
         </p:nvSpPr>
@@ -4455,7 +4599,7 @@
       </p:grpSpPr>
       <p:sp>
         <p:nvSpPr>
-          <p:cNvPr id="59" name=""/>
+          <p:cNvPr id="61" name=""/>
           <p:cNvSpPr txBox="1"/>
           <p:nvPr/>
         </p:nvSpPr>
@@ -4498,7 +4642,7 @@
       </p:sp>
       <p:sp>
         <p:nvSpPr>
-          <p:cNvPr id="60" name=""/>
+          <p:cNvPr id="62" name=""/>
           <p:cNvSpPr txBox="1"/>
           <p:nvPr/>
         </p:nvSpPr>
@@ -4541,7 +4685,7 @@
       </p:sp>
       <p:sp>
         <p:nvSpPr>
-          <p:cNvPr id="61" name="PlaceHolder 1"/>
+          <p:cNvPr id="63" name="PlaceHolder 1"/>
           <p:cNvSpPr>
             <a:spLocks noGrp="1"/>
           </p:cNvSpPr>
@@ -4638,7 +4782,7 @@
       </p:grpSpPr>
       <p:sp>
         <p:nvSpPr>
-          <p:cNvPr id="62" name="PlaceHolder 1"/>
+          <p:cNvPr id="64" name="PlaceHolder 1"/>
           <p:cNvSpPr>
             <a:spLocks noGrp="1"/>
           </p:cNvSpPr>
@@ -4687,7 +4831,7 @@
       </p:sp>
       <p:sp>
         <p:nvSpPr>
-          <p:cNvPr id="63" name=""/>
+          <p:cNvPr id="65" name=""/>
           <p:cNvSpPr/>
           <p:nvPr/>
         </p:nvSpPr>
@@ -4728,7 +4872,7 @@
       </p:sp>
       <p:sp>
         <p:nvSpPr>
-          <p:cNvPr id="64" name="PlaceHolder 2"/>
+          <p:cNvPr id="66" name="PlaceHolder 2"/>
           <p:cNvSpPr>
             <a:spLocks noGrp="1"/>
           </p:cNvSpPr>
@@ -4922,7 +5066,7 @@
       </p:sp>
       <p:sp>
         <p:nvSpPr>
-          <p:cNvPr id="65" name=""/>
+          <p:cNvPr id="67" name=""/>
           <p:cNvSpPr txBox="1"/>
           <p:nvPr/>
         </p:nvSpPr>
@@ -5054,7 +5198,7 @@
       </p:sp>
       <p:grpSp>
         <p:nvGrpSpPr>
-          <p:cNvPr id="66" name=""/>
+          <p:cNvPr id="68" name=""/>
           <p:cNvGrpSpPr/>
           <p:nvPr/>
         </p:nvGrpSpPr>
@@ -5068,7 +5212,7 @@
         </p:grpSpPr>
         <p:sp>
           <p:nvSpPr>
-            <p:cNvPr id="67" name=""/>
+            <p:cNvPr id="69" name=""/>
             <p:cNvSpPr/>
             <p:nvPr/>
           </p:nvSpPr>
@@ -5118,7 +5262,7 @@
         </p:sp>
         <p:sp>
           <p:nvSpPr>
-            <p:cNvPr id="68" name=""/>
+            <p:cNvPr id="70" name=""/>
             <p:cNvSpPr/>
             <p:nvPr/>
           </p:nvSpPr>
@@ -5169,7 +5313,7 @@
       </p:grpSp>
       <p:sp>
         <p:nvSpPr>
-          <p:cNvPr id="69" name=""/>
+          <p:cNvPr id="71" name=""/>
           <p:cNvSpPr txBox="1"/>
           <p:nvPr/>
         </p:nvSpPr>
@@ -5262,7 +5406,7 @@
       </p:grpSpPr>
       <p:sp>
         <p:nvSpPr>
-          <p:cNvPr id="70" name="PlaceHolder 1"/>
+          <p:cNvPr id="72" name="PlaceHolder 1"/>
           <p:cNvSpPr>
             <a:spLocks noGrp="1"/>
           </p:cNvSpPr>
@@ -5311,7 +5455,7 @@
       </p:sp>
       <p:sp>
         <p:nvSpPr>
-          <p:cNvPr id="71" name=""/>
+          <p:cNvPr id="73" name=""/>
           <p:cNvSpPr/>
           <p:nvPr/>
         </p:nvSpPr>
@@ -5352,7 +5496,7 @@
       </p:sp>
       <p:grpSp>
         <p:nvGrpSpPr>
-          <p:cNvPr id="72" name=""/>
+          <p:cNvPr id="74" name=""/>
           <p:cNvGrpSpPr/>
           <p:nvPr/>
         </p:nvGrpSpPr>
@@ -5366,7 +5510,7 @@
         </p:grpSpPr>
         <p:sp>
           <p:nvSpPr>
-            <p:cNvPr id="73" name=""/>
+            <p:cNvPr id="75" name=""/>
             <p:cNvSpPr/>
             <p:nvPr/>
           </p:nvSpPr>
@@ -5570,7 +5714,7 @@
         </p:sp>
         <p:sp>
           <p:nvSpPr>
-            <p:cNvPr id="74" name=""/>
+            <p:cNvPr id="76" name=""/>
             <p:cNvSpPr/>
             <p:nvPr/>
           </p:nvSpPr>
@@ -5623,7 +5767,7 @@
       </p:grpSp>
       <p:grpSp>
         <p:nvGrpSpPr>
-          <p:cNvPr id="75" name=""/>
+          <p:cNvPr id="77" name=""/>
           <p:cNvGrpSpPr/>
           <p:nvPr/>
         </p:nvGrpSpPr>
@@ -5637,7 +5781,7 @@
         </p:grpSpPr>
         <p:sp>
           <p:nvSpPr>
-            <p:cNvPr id="76" name=""/>
+            <p:cNvPr id="78" name=""/>
             <p:cNvSpPr/>
             <p:nvPr/>
           </p:nvSpPr>
@@ -5823,7 +5967,7 @@
         </p:sp>
         <p:sp>
           <p:nvSpPr>
-            <p:cNvPr id="77" name=""/>
+            <p:cNvPr id="79" name=""/>
             <p:cNvSpPr/>
             <p:nvPr/>
           </p:nvSpPr>
@@ -5912,7 +6056,7 @@
       </p:grpSp>
       <p:grpSp>
         <p:nvGrpSpPr>
-          <p:cNvPr id="78" name=""/>
+          <p:cNvPr id="80" name=""/>
           <p:cNvGrpSpPr/>
           <p:nvPr/>
         </p:nvGrpSpPr>
@@ -5926,7 +6070,7 @@
         </p:grpSpPr>
         <p:sp>
           <p:nvSpPr>
-            <p:cNvPr id="79" name=""/>
+            <p:cNvPr id="81" name=""/>
             <p:cNvSpPr/>
             <p:nvPr/>
           </p:nvSpPr>
@@ -5977,7 +6121,7 @@
         </p:sp>
         <p:sp>
           <p:nvSpPr>
-            <p:cNvPr id="80" name=""/>
+            <p:cNvPr id="82" name=""/>
             <p:cNvSpPr/>
             <p:nvPr/>
           </p:nvSpPr>
@@ -6030,7 +6174,7 @@
       </p:grpSp>
       <p:sp>
         <p:nvSpPr>
-          <p:cNvPr id="81" name=""/>
+          <p:cNvPr id="83" name=""/>
           <p:cNvSpPr/>
           <p:nvPr/>
         </p:nvSpPr>
@@ -6081,7 +6225,7 @@
       </p:sp>
       <p:sp>
         <p:nvSpPr>
-          <p:cNvPr id="82" name=""/>
+          <p:cNvPr id="84" name=""/>
           <p:cNvSpPr txBox="1"/>
           <p:nvPr/>
         </p:nvSpPr>
@@ -6123,7 +6267,7 @@
       </p:sp>
       <p:sp>
         <p:nvSpPr>
-          <p:cNvPr id="83" name=""/>
+          <p:cNvPr id="85" name=""/>
           <p:cNvSpPr/>
           <p:nvPr/>
         </p:nvSpPr>
@@ -6174,7 +6318,7 @@
       </p:sp>
       <p:sp>
         <p:nvSpPr>
-          <p:cNvPr id="84" name=""/>
+          <p:cNvPr id="86" name=""/>
           <p:cNvSpPr txBox="1"/>
           <p:nvPr/>
         </p:nvSpPr>
@@ -6216,7 +6360,7 @@
       </p:sp>
       <p:sp>
         <p:nvSpPr>
-          <p:cNvPr id="85" name=""/>
+          <p:cNvPr id="87" name=""/>
           <p:cNvSpPr/>
           <p:nvPr/>
         </p:nvSpPr>
@@ -6267,7 +6411,7 @@
       </p:sp>
       <p:sp>
         <p:nvSpPr>
-          <p:cNvPr id="86" name=""/>
+          <p:cNvPr id="88" name=""/>
           <p:cNvSpPr txBox="1"/>
           <p:nvPr/>
         </p:nvSpPr>
@@ -6309,7 +6453,7 @@
       </p:sp>
       <p:grpSp>
         <p:nvGrpSpPr>
-          <p:cNvPr id="87" name=""/>
+          <p:cNvPr id="89" name=""/>
           <p:cNvGrpSpPr/>
           <p:nvPr/>
         </p:nvGrpSpPr>
@@ -6323,7 +6467,7 @@
         </p:grpSpPr>
         <p:sp>
           <p:nvSpPr>
-            <p:cNvPr id="88" name=""/>
+            <p:cNvPr id="90" name=""/>
             <p:cNvSpPr/>
             <p:nvPr/>
           </p:nvSpPr>
@@ -6473,7 +6617,7 @@
         </p:sp>
         <p:sp>
           <p:nvSpPr>
-            <p:cNvPr id="89" name=""/>
+            <p:cNvPr id="91" name=""/>
             <p:cNvSpPr/>
             <p:nvPr/>
           </p:nvSpPr>
@@ -6526,7 +6670,7 @@
       </p:grpSp>
       <p:sp>
         <p:nvSpPr>
-          <p:cNvPr id="90" name=""/>
+          <p:cNvPr id="92" name=""/>
           <p:cNvSpPr txBox="1"/>
           <p:nvPr/>
         </p:nvSpPr>
@@ -6619,7 +6763,7 @@
       </p:grpSpPr>
       <p:sp>
         <p:nvSpPr>
-          <p:cNvPr id="91" name="PlaceHolder 1"/>
+          <p:cNvPr id="93" name="PlaceHolder 1"/>
           <p:cNvSpPr>
             <a:spLocks noGrp="1"/>
           </p:cNvSpPr>
@@ -6668,7 +6812,7 @@
       </p:sp>
       <p:sp>
         <p:nvSpPr>
-          <p:cNvPr id="92" name=""/>
+          <p:cNvPr id="94" name=""/>
           <p:cNvSpPr/>
           <p:nvPr/>
         </p:nvSpPr>
@@ -6709,7 +6853,7 @@
       </p:sp>
       <p:sp>
         <p:nvSpPr>
-          <p:cNvPr id="93" name=""/>
+          <p:cNvPr id="95" name=""/>
           <p:cNvSpPr/>
           <p:nvPr/>
         </p:nvSpPr>
@@ -6824,7 +6968,7 @@
       </p:sp>
       <p:sp>
         <p:nvSpPr>
-          <p:cNvPr id="94" name=""/>
+          <p:cNvPr id="96" name=""/>
           <p:cNvSpPr/>
           <p:nvPr/>
         </p:nvSpPr>
@@ -6939,7 +7083,7 @@
       </p:sp>
       <p:sp>
         <p:nvSpPr>
-          <p:cNvPr id="95" name=""/>
+          <p:cNvPr id="97" name=""/>
           <p:cNvSpPr/>
           <p:nvPr/>
         </p:nvSpPr>
@@ -7058,7 +7202,7 @@
       </p:sp>
       <p:sp>
         <p:nvSpPr>
-          <p:cNvPr id="96" name=""/>
+          <p:cNvPr id="98" name=""/>
           <p:cNvSpPr/>
           <p:nvPr/>
         </p:nvSpPr>
@@ -7137,7 +7281,7 @@
       </p:sp>
       <p:sp>
         <p:nvSpPr>
-          <p:cNvPr id="97" name=""/>
+          <p:cNvPr id="99" name=""/>
           <p:cNvSpPr/>
           <p:nvPr/>
         </p:nvSpPr>
@@ -7216,7 +7360,7 @@
       </p:sp>
       <p:sp>
         <p:nvSpPr>
-          <p:cNvPr id="98" name=""/>
+          <p:cNvPr id="100" name=""/>
           <p:cNvSpPr/>
           <p:nvPr/>
         </p:nvSpPr>
@@ -7295,7 +7439,7 @@
       </p:sp>
       <p:sp>
         <p:nvSpPr>
-          <p:cNvPr id="99" name=""/>
+          <p:cNvPr id="101" name=""/>
           <p:cNvSpPr/>
           <p:nvPr/>
         </p:nvSpPr>
@@ -7453,7 +7597,7 @@
       </p:sp>
       <p:sp>
         <p:nvSpPr>
-          <p:cNvPr id="100" name=""/>
+          <p:cNvPr id="102" name=""/>
           <p:cNvSpPr/>
           <p:nvPr/>
         </p:nvSpPr>
@@ -7550,7 +7694,7 @@
       </p:sp>
       <p:sp>
         <p:nvSpPr>
-          <p:cNvPr id="101" name=""/>
+          <p:cNvPr id="103" name=""/>
           <p:cNvSpPr txBox="1"/>
           <p:nvPr/>
         </p:nvSpPr>
@@ -7643,7 +7787,7 @@
       </p:grpSpPr>
       <p:sp>
         <p:nvSpPr>
-          <p:cNvPr id="102" name=""/>
+          <p:cNvPr id="104" name=""/>
           <p:cNvSpPr txBox="1"/>
           <p:nvPr/>
         </p:nvSpPr>
@@ -7686,7 +7830,7 @@
       </p:sp>
       <p:sp>
         <p:nvSpPr>
-          <p:cNvPr id="103" name=""/>
+          <p:cNvPr id="105" name=""/>
           <p:cNvSpPr txBox="1"/>
           <p:nvPr/>
         </p:nvSpPr>
@@ -7729,7 +7873,7 @@
       </p:sp>
       <p:sp>
         <p:nvSpPr>
-          <p:cNvPr id="104" name="PlaceHolder 1"/>
+          <p:cNvPr id="106" name="PlaceHolder 1"/>
           <p:cNvSpPr>
             <a:spLocks noGrp="1"/>
           </p:cNvSpPr>
@@ -7808,7 +7952,7 @@
       </p:grpSpPr>
       <p:sp>
         <p:nvSpPr>
-          <p:cNvPr id="105" name="PlaceHolder 1"/>
+          <p:cNvPr id="107" name="PlaceHolder 1"/>
           <p:cNvSpPr>
             <a:spLocks noGrp="1"/>
           </p:cNvSpPr>
@@ -7857,7 +8001,7 @@
       </p:sp>
       <p:sp>
         <p:nvSpPr>
-          <p:cNvPr id="106" name=""/>
+          <p:cNvPr id="108" name=""/>
           <p:cNvSpPr/>
           <p:nvPr/>
         </p:nvSpPr>
@@ -7898,7 +8042,7 @@
       </p:sp>
       <p:sp>
         <p:nvSpPr>
-          <p:cNvPr id="107" name=""/>
+          <p:cNvPr id="109" name=""/>
           <p:cNvSpPr/>
           <p:nvPr/>
         </p:nvSpPr>
@@ -7977,7 +8121,7 @@
       </p:sp>
       <p:sp>
         <p:nvSpPr>
-          <p:cNvPr id="108" name=""/>
+          <p:cNvPr id="110" name=""/>
           <p:cNvSpPr txBox="1"/>
           <p:nvPr/>
         </p:nvSpPr>
@@ -8020,7 +8164,7 @@
       </p:sp>
       <p:sp>
         <p:nvSpPr>
-          <p:cNvPr id="109" name=""/>
+          <p:cNvPr id="111" name=""/>
           <p:cNvSpPr/>
           <p:nvPr/>
         </p:nvSpPr>
@@ -8062,7 +8206,7 @@
       </p:sp>
       <p:sp>
         <p:nvSpPr>
-          <p:cNvPr id="110" name=""/>
+          <p:cNvPr id="112" name=""/>
           <p:cNvSpPr/>
           <p:nvPr/>
         </p:nvSpPr>
@@ -8141,7 +8285,7 @@
       </p:sp>
       <p:sp>
         <p:nvSpPr>
-          <p:cNvPr id="111" name=""/>
+          <p:cNvPr id="113" name=""/>
           <p:cNvSpPr txBox="1"/>
           <p:nvPr/>
         </p:nvSpPr>
@@ -8184,7 +8328,7 @@
       </p:sp>
       <p:sp>
         <p:nvSpPr>
-          <p:cNvPr id="112" name=""/>
+          <p:cNvPr id="114" name=""/>
           <p:cNvSpPr/>
           <p:nvPr/>
         </p:nvSpPr>
@@ -8226,7 +8370,7 @@
       </p:sp>
       <p:sp>
         <p:nvSpPr>
-          <p:cNvPr id="113" name=""/>
+          <p:cNvPr id="115" name=""/>
           <p:cNvSpPr/>
           <p:nvPr/>
         </p:nvSpPr>
@@ -8305,7 +8449,7 @@
       </p:sp>
       <p:sp>
         <p:nvSpPr>
-          <p:cNvPr id="114" name=""/>
+          <p:cNvPr id="116" name=""/>
           <p:cNvSpPr txBox="1"/>
           <p:nvPr/>
         </p:nvSpPr>
@@ -8348,7 +8492,7 @@
       </p:sp>
       <p:sp>
         <p:nvSpPr>
-          <p:cNvPr id="115" name=""/>
+          <p:cNvPr id="117" name=""/>
           <p:cNvSpPr/>
           <p:nvPr/>
         </p:nvSpPr>
@@ -8390,7 +8534,7 @@
       </p:sp>
       <p:sp>
         <p:nvSpPr>
-          <p:cNvPr id="116" name=""/>
+          <p:cNvPr id="118" name=""/>
           <p:cNvSpPr/>
           <p:nvPr/>
         </p:nvSpPr>
@@ -8469,7 +8613,7 @@
       </p:sp>
       <p:sp>
         <p:nvSpPr>
-          <p:cNvPr id="117" name=""/>
+          <p:cNvPr id="119" name=""/>
           <p:cNvSpPr txBox="1"/>
           <p:nvPr/>
         </p:nvSpPr>
@@ -8512,7 +8656,7 @@
       </p:sp>
       <p:sp>
         <p:nvSpPr>
-          <p:cNvPr id="118" name=""/>
+          <p:cNvPr id="120" name=""/>
           <p:cNvSpPr/>
           <p:nvPr/>
         </p:nvSpPr>
@@ -8556,7 +8700,7 @@
       </p:sp>
       <p:sp>
         <p:nvSpPr>
-          <p:cNvPr id="119" name=""/>
+          <p:cNvPr id="121" name=""/>
           <p:cNvSpPr/>
           <p:nvPr/>
         </p:nvSpPr>
@@ -8609,7 +8753,7 @@
       </p:sp>
       <p:grpSp>
         <p:nvGrpSpPr>
-          <p:cNvPr id="120" name=""/>
+          <p:cNvPr id="122" name=""/>
           <p:cNvGrpSpPr/>
           <p:nvPr/>
         </p:nvGrpSpPr>
@@ -8623,7 +8767,7 @@
         </p:grpSpPr>
         <p:sp>
           <p:nvSpPr>
-            <p:cNvPr id="121" name=""/>
+            <p:cNvPr id="123" name=""/>
             <p:cNvSpPr/>
             <p:nvPr/>
           </p:nvSpPr>
@@ -8683,7 +8827,7 @@
         </p:sp>
         <p:sp>
           <p:nvSpPr>
-            <p:cNvPr id="122" name=""/>
+            <p:cNvPr id="124" name=""/>
             <p:cNvSpPr/>
             <p:nvPr/>
           </p:nvSpPr>
@@ -8736,7 +8880,7 @@
       </p:grpSp>
       <p:grpSp>
         <p:nvGrpSpPr>
-          <p:cNvPr id="123" name=""/>
+          <p:cNvPr id="125" name=""/>
           <p:cNvGrpSpPr/>
           <p:nvPr/>
         </p:nvGrpSpPr>
@@ -8750,7 +8894,7 @@
         </p:grpSpPr>
         <p:sp>
           <p:nvSpPr>
-            <p:cNvPr id="124" name=""/>
+            <p:cNvPr id="126" name=""/>
             <p:cNvSpPr/>
             <p:nvPr/>
           </p:nvSpPr>
@@ -8810,7 +8954,7 @@
         </p:sp>
         <p:sp>
           <p:nvSpPr>
-            <p:cNvPr id="125" name=""/>
+            <p:cNvPr id="127" name=""/>
             <p:cNvSpPr/>
             <p:nvPr/>
           </p:nvSpPr>
@@ -8863,7 +9007,7 @@
       </p:grpSp>
       <p:grpSp>
         <p:nvGrpSpPr>
-          <p:cNvPr id="126" name=""/>
+          <p:cNvPr id="128" name=""/>
           <p:cNvGrpSpPr/>
           <p:nvPr/>
         </p:nvGrpSpPr>
@@ -8877,7 +9021,7 @@
         </p:grpSpPr>
         <p:sp>
           <p:nvSpPr>
-            <p:cNvPr id="127" name=""/>
+            <p:cNvPr id="129" name=""/>
             <p:cNvSpPr/>
             <p:nvPr/>
           </p:nvSpPr>
@@ -8937,7 +9081,7 @@
         </p:sp>
         <p:sp>
           <p:nvSpPr>
-            <p:cNvPr id="128" name=""/>
+            <p:cNvPr id="130" name=""/>
             <p:cNvSpPr/>
             <p:nvPr/>
           </p:nvSpPr>
@@ -8990,7 +9134,7 @@
       </p:grpSp>
       <p:sp>
         <p:nvSpPr>
-          <p:cNvPr id="129" name=""/>
+          <p:cNvPr id="131" name=""/>
           <p:cNvSpPr txBox="1"/>
           <p:nvPr/>
         </p:nvSpPr>
@@ -9083,7 +9227,7 @@
       </p:grpSpPr>
       <p:sp>
         <p:nvSpPr>
-          <p:cNvPr id="130" name="PlaceHolder 1"/>
+          <p:cNvPr id="132" name="PlaceHolder 1"/>
           <p:cNvSpPr>
             <a:spLocks noGrp="1"/>
           </p:cNvSpPr>
@@ -9132,7 +9276,7 @@
       </p:sp>
       <p:sp>
         <p:nvSpPr>
-          <p:cNvPr id="131" name=""/>
+          <p:cNvPr id="133" name=""/>
           <p:cNvSpPr/>
           <p:nvPr/>
         </p:nvSpPr>
@@ -9173,7 +9317,7 @@
       </p:sp>
       <p:graphicFrame>
         <p:nvGraphicFramePr>
-          <p:cNvPr id="132" name=""/>
+          <p:cNvPr id="134" name=""/>
           <p:cNvGraphicFramePr/>
           <p:nvPr/>
         </p:nvGraphicFramePr>
@@ -9963,7 +10107,7 @@
       </p:graphicFrame>
       <p:sp>
         <p:nvSpPr>
-          <p:cNvPr id="133" name=""/>
+          <p:cNvPr id="135" name=""/>
           <p:cNvSpPr txBox="1"/>
           <p:nvPr/>
         </p:nvSpPr>

</xml_diff>